<commit_message>
fix: resolve Windows console UTF-8 encoding for section markers and add submission deliverables
</commit_message>
<xml_diff>
--- a/CollegeName_TeamName_Submission.pptx
+++ b/CollegeName_TeamName_Submission.pptx
@@ -5222,43 +5222,6 @@
               </a:solidFill>
               <a:latin typeface="Calibri"/>
             </a:endParaRPr>
-          </a:p>
-        </p:txBody>
-      </p:sp>
-      <p:sp>
-        <p:nvSpPr>
-          <p:cNvPr id="30" name="TextBox 29"/>
-          <p:cNvSpPr txBox="1"/>
-          <p:nvPr/>
-        </p:nvSpPr>
-        <p:spPr>
-          <a:xfrm>
-            <a:off x="1042415" y="4663440"/>
-            <a:ext cx="1283044" cy="584775"/>
-          </a:xfrm>
-          <a:prstGeom prst="rect">
-            <a:avLst/>
-          </a:prstGeom>
-          <a:noFill/>
-        </p:spPr>
-        <p:txBody>
-          <a:bodyPr wrap="none">
-            <a:spAutoFit/>
-          </a:bodyPr>
-          <a:lstStyle/>
-          <a:p>
-            <a:endParaRPr dirty="0"/>
-          </a:p>
-          <a:p>
-            <a:r>
-              <a:rPr sz="1400" b="1" dirty="0">
-                <a:solidFill>
-                  <a:srgbClr val="D9383A"/>
-                </a:solidFill>
-                <a:latin typeface="Calibri"/>
-              </a:rPr>
-              <a:t>Team Contact: </a:t>
-            </a:r>
           </a:p>
         </p:txBody>
       </p:sp>

</xml_diff>